<commit_message>
Sync Walt's deck: small hand-edit from Drive
</commit_message>
<xml_diff>
--- a/deliverables/speaker-decks/Walt Brown — 7 Critical Needs (fixed) (4).pptx
+++ b/deliverables/speaker-decks/Walt Brown — 7 Critical Needs (fixed) (4).pptx
@@ -8440,6 +8440,37 @@
             </a:r>
             <a:endParaRPr/>
           </a:p>
+          <a:p>
+            <a:pPr indent="0" lvl="0" marL="0" rtl="0" algn="l">
+              <a:spcBef>
+                <a:spcPts val="0"/>
+              </a:spcBef>
+              <a:spcAft>
+                <a:spcPts val="0"/>
+              </a:spcAft>
+              <a:buNone/>
+            </a:pPr>
+            <a:r>
+              <a:t/>
+            </a:r>
+            <a:endParaRPr/>
+          </a:p>
+          <a:p>
+            <a:pPr indent="0" lvl="0" marL="0" rtl="0" algn="l">
+              <a:spcBef>
+                <a:spcPts val="0"/>
+              </a:spcBef>
+              <a:spcAft>
+                <a:spcPts val="0"/>
+              </a:spcAft>
+              <a:buNone/>
+            </a:pPr>
+            <a:r>
+              <a:rPr lang="en-US"/>
+              <a:t>EOS makes Healthy Actionable - im going to point out that the 7 Critical Needs makes Healthy Measurable </a:t>
+            </a:r>
+            <a:endParaRPr/>
+          </a:p>
         </p:txBody>
       </p:sp>
       <p:sp>
@@ -8744,7 +8775,7 @@
             </a:r>
             <a:r>
               <a:rPr lang="en-US" sz="1500"/>
-              <a:t> become more accountable and disciplined,</a:t>
+              <a:t> become more accountable and disciplined, rowing together</a:t>
             </a:r>
             <a:endParaRPr/>
           </a:p>
@@ -8760,7 +8791,7 @@
             </a:pPr>
             <a:r>
               <a:rPr lang="en-US" sz="1500"/>
-              <a:t>executing really well to achieve every part of your vision. Your leaders Rowing together. </a:t>
+              <a:t>executing really well to achieve every part of your vision.  </a:t>
             </a:r>
             <a:endParaRPr/>
           </a:p>
@@ -9302,10 +9333,10 @@
               <a:buNone/>
             </a:pPr>
             <a:r>
-              <a:rPr lang="en-US" sz="1800"/>
+              <a:rPr lang="en-US" sz="1300"/>
               <a:t>And this is what I'm here to talk to you about today </a:t>
             </a:r>
-            <a:endParaRPr/>
+            <a:endParaRPr sz="700"/>
           </a:p>
           <a:p>
             <a:pPr indent="0" lvl="0" marL="0" rtl="0" algn="l">
@@ -9320,7 +9351,7 @@
             <a:r>
               <a:t/>
             </a:r>
-            <a:endParaRPr/>
+            <a:endParaRPr sz="700"/>
           </a:p>
           <a:p>
             <a:pPr indent="0" lvl="0" marL="0" rtl="0" algn="l">
@@ -9333,26 +9364,26 @@
               <a:buNone/>
             </a:pPr>
             <a:r>
-              <a:rPr lang="en-US" sz="1800"/>
+              <a:rPr lang="en-US" sz="1300"/>
               <a:t>Yeah, EOS does an amazing job in creating clarity around vision at the </a:t>
             </a:r>
             <a:r>
-              <a:rPr b="1" lang="en-US"/>
+              <a:rPr b="1" lang="en-US" sz="700"/>
               <a:t>Sr. Leadership Team</a:t>
             </a:r>
             <a:r>
-              <a:rPr lang="en-US" sz="1800"/>
+              <a:rPr lang="en-US" sz="1300"/>
               <a:t> Level, and it does a great job to create traction, individual accountability and discipline, at the </a:t>
             </a:r>
             <a:r>
-              <a:rPr b="1" lang="en-US"/>
+              <a:rPr b="1" lang="en-US" sz="700"/>
               <a:t>Sr. Leadership Team</a:t>
             </a:r>
             <a:r>
-              <a:rPr lang="en-US" sz="1800"/>
+              <a:rPr lang="en-US" sz="1300"/>
               <a:t> Level.</a:t>
             </a:r>
-            <a:endParaRPr/>
+            <a:endParaRPr sz="700"/>
           </a:p>
           <a:p>
             <a:pPr indent="0" lvl="0" marL="0" rtl="0" algn="l">
@@ -9367,7 +9398,7 @@
             <a:r>
               <a:t/>
             </a:r>
-            <a:endParaRPr/>
+            <a:endParaRPr sz="700"/>
           </a:p>
           <a:p>
             <a:pPr indent="0" lvl="0" marL="0" rtl="0" algn="l">
@@ -9380,14 +9411,14 @@
               <a:buNone/>
             </a:pPr>
             <a:r>
-              <a:rPr lang="en-US" sz="1800"/>
+              <a:rPr lang="en-US" sz="1300"/>
               <a:t>And it does a great job at creating healthy, functional cohesive </a:t>
             </a:r>
             <a:r>
-              <a:rPr b="1" lang="en-US"/>
+              <a:rPr b="1" lang="en-US" sz="700"/>
               <a:t>Senior leadership Teams</a:t>
             </a:r>
-            <a:endParaRPr/>
+            <a:endParaRPr sz="700"/>
           </a:p>
           <a:p>
             <a:pPr indent="0" lvl="0" marL="0" rtl="0" algn="l">
@@ -9402,7 +9433,7 @@
             <a:r>
               <a:t/>
             </a:r>
-            <a:endParaRPr b="1"/>
+            <a:endParaRPr b="1" sz="700"/>
           </a:p>
           <a:p>
             <a:pPr indent="0" lvl="0" marL="0" rtl="0" algn="l">
@@ -9415,10 +9446,10 @@
               <a:buNone/>
             </a:pPr>
             <a:r>
-              <a:rPr lang="en-US" sz="1800"/>
+              <a:rPr lang="en-US" sz="1300"/>
               <a:t>Nobody can match us here.</a:t>
             </a:r>
-            <a:endParaRPr/>
+            <a:endParaRPr sz="700"/>
           </a:p>
           <a:p>
             <a:pPr indent="0" lvl="0" marL="0" rtl="0" algn="l">
@@ -9433,7 +9464,7 @@
             <a:r>
               <a:t/>
             </a:r>
-            <a:endParaRPr/>
+            <a:endParaRPr sz="700"/>
           </a:p>
           <a:p>
             <a:pPr indent="0" lvl="0" marL="0" rtl="0" algn="l">
@@ -9446,18 +9477,18 @@
               <a:buNone/>
             </a:pPr>
             <a:r>
-              <a:rPr lang="en-US" sz="1800"/>
+              <a:rPr lang="en-US" sz="1300"/>
               <a:t>And </a:t>
             </a:r>
             <a:r>
-              <a:rPr lang="en-US" sz="1800"/>
+              <a:rPr lang="en-US" sz="1300"/>
               <a:t>oftentimes</a:t>
             </a:r>
             <a:r>
-              <a:rPr lang="en-US" sz="1800"/>
+              <a:rPr lang="en-US" sz="1300"/>
               <a:t>, for smaller companies, for the original core target of EOS, this is enough.</a:t>
             </a:r>
-            <a:endParaRPr/>
+            <a:endParaRPr sz="700"/>
           </a:p>
           <a:p>
             <a:pPr indent="0" lvl="0" marL="0" rtl="0" algn="l">
@@ -16198,31 +16229,7 @@
                 <a:cs typeface="League Spartan"/>
                 <a:sym typeface="League Spartan"/>
               </a:rPr>
-              <a:t>An </a:t>
-            </a:r>
-            <a:r>
-              <a:rPr b="1" lang="en-US" sz="6270" u="sng">
-                <a:solidFill>
-                  <a:srgbClr val="FFFFFF"/>
-                </a:solidFill>
-                <a:latin typeface="League Spartan"/>
-                <a:ea typeface="League Spartan"/>
-                <a:cs typeface="League Spartan"/>
-                <a:sym typeface="League Spartan"/>
-              </a:rPr>
-              <a:t>Actionable</a:t>
-            </a:r>
-            <a:r>
-              <a:rPr b="1" lang="en-US" sz="6270">
-                <a:solidFill>
-                  <a:srgbClr val="FFFFFF"/>
-                </a:solidFill>
-                <a:latin typeface="League Spartan"/>
-                <a:ea typeface="League Spartan"/>
-                <a:cs typeface="League Spartan"/>
-                <a:sym typeface="League Spartan"/>
-              </a:rPr>
-              <a:t> Advantage</a:t>
+              <a:t>Actionable Advantage</a:t>
             </a:r>
             <a:endParaRPr b="1" sz="6270">
               <a:solidFill>
@@ -17365,19 +17372,7 @@
               <a:buNone/>
             </a:pPr>
             <a:r>
-              <a:rPr b="1" lang="en-US" sz="6270">
-                <a:solidFill>
-                  <a:srgbClr val="FFFFFF"/>
-                </a:solidFill>
-                <a:latin typeface="League Spartan"/>
-                <a:ea typeface="League Spartan"/>
-                <a:cs typeface="League Spartan"/>
-                <a:sym typeface="League Spartan"/>
-              </a:rPr>
-              <a:t>An </a:t>
-            </a:r>
-            <a:r>
-              <a:rPr b="1" lang="en-US" sz="6270" u="sng">
+              <a:rPr b="1" i="1" lang="en-US" sz="6270">
                 <a:solidFill>
                   <a:srgbClr val="FFFFFF"/>
                 </a:solidFill>
@@ -22138,8 +22133,8 @@
         </p:nvSpPr>
         <p:spPr>
           <a:xfrm>
-            <a:off x="0" y="-1"/>
-            <a:ext cx="18287960" cy="10286979"/>
+            <a:off x="0" y="18468"/>
+            <a:ext cx="18288000" cy="10287000"/>
           </a:xfrm>
           <a:prstGeom prst="rect">
             <a:avLst/>
@@ -22337,7 +22332,31 @@
                 <a:cs typeface="League Spartan"/>
                 <a:sym typeface="League Spartan"/>
               </a:rPr>
-              <a:t>Questions became needs:</a:t>
+              <a:t>Questions became </a:t>
+            </a:r>
+            <a:r>
+              <a:rPr b="1" lang="en-US" sz="8545">
+                <a:solidFill>
+                  <a:srgbClr val="F04E23"/>
+                </a:solidFill>
+                <a:latin typeface="League Spartan"/>
+                <a:ea typeface="League Spartan"/>
+                <a:cs typeface="League Spartan"/>
+                <a:sym typeface="League Spartan"/>
+              </a:rPr>
+              <a:t>N</a:t>
+            </a:r>
+            <a:r>
+              <a:rPr b="1" i="0" lang="en-US" sz="8545" u="none" cap="none" strike="noStrike">
+                <a:solidFill>
+                  <a:srgbClr val="F04E23"/>
+                </a:solidFill>
+                <a:latin typeface="League Spartan"/>
+                <a:ea typeface="League Spartan"/>
+                <a:cs typeface="League Spartan"/>
+                <a:sym typeface="League Spartan"/>
+              </a:rPr>
+              <a:t>eeds:</a:t>
             </a:r>
             <a:endParaRPr sz="600"/>
           </a:p>
@@ -22786,7 +22805,31 @@
                 <a:cs typeface="League Spartan"/>
                 <a:sym typeface="League Spartan"/>
               </a:rPr>
-              <a:t>Questions became needs:</a:t>
+              <a:t>Questions became </a:t>
+            </a:r>
+            <a:r>
+              <a:rPr b="1" lang="en-US" sz="8545">
+                <a:solidFill>
+                  <a:srgbClr val="F04E23"/>
+                </a:solidFill>
+                <a:latin typeface="League Spartan"/>
+                <a:ea typeface="League Spartan"/>
+                <a:cs typeface="League Spartan"/>
+                <a:sym typeface="League Spartan"/>
+              </a:rPr>
+              <a:t>N</a:t>
+            </a:r>
+            <a:r>
+              <a:rPr b="1" i="0" lang="en-US" sz="8545" u="none" cap="none" strike="noStrike">
+                <a:solidFill>
+                  <a:srgbClr val="F04E23"/>
+                </a:solidFill>
+                <a:latin typeface="League Spartan"/>
+                <a:ea typeface="League Spartan"/>
+                <a:cs typeface="League Spartan"/>
+                <a:sym typeface="League Spartan"/>
+              </a:rPr>
+              <a:t>eeds:</a:t>
             </a:r>
             <a:endParaRPr sz="600"/>
           </a:p>
@@ -23203,7 +23246,31 @@
                 <a:cs typeface="League Spartan"/>
                 <a:sym typeface="League Spartan"/>
               </a:rPr>
-              <a:t>Questions became needs:</a:t>
+              <a:t>Questions became </a:t>
+            </a:r>
+            <a:r>
+              <a:rPr b="1" lang="en-US" sz="8545">
+                <a:solidFill>
+                  <a:srgbClr val="F04E23"/>
+                </a:solidFill>
+                <a:latin typeface="League Spartan"/>
+                <a:ea typeface="League Spartan"/>
+                <a:cs typeface="League Spartan"/>
+                <a:sym typeface="League Spartan"/>
+              </a:rPr>
+              <a:t>N</a:t>
+            </a:r>
+            <a:r>
+              <a:rPr b="1" i="0" lang="en-US" sz="8545" u="none" cap="none" strike="noStrike">
+                <a:solidFill>
+                  <a:srgbClr val="F04E23"/>
+                </a:solidFill>
+                <a:latin typeface="League Spartan"/>
+                <a:ea typeface="League Spartan"/>
+                <a:cs typeface="League Spartan"/>
+                <a:sym typeface="League Spartan"/>
+              </a:rPr>
+              <a:t>eeds:</a:t>
             </a:r>
             <a:endParaRPr sz="600"/>
           </a:p>
@@ -23620,7 +23687,31 @@
                 <a:cs typeface="League Spartan"/>
                 <a:sym typeface="League Spartan"/>
               </a:rPr>
-              <a:t>Questions became needs:</a:t>
+              <a:t>Questions became </a:t>
+            </a:r>
+            <a:r>
+              <a:rPr b="1" lang="en-US" sz="8545">
+                <a:solidFill>
+                  <a:srgbClr val="F04E23"/>
+                </a:solidFill>
+                <a:latin typeface="League Spartan"/>
+                <a:ea typeface="League Spartan"/>
+                <a:cs typeface="League Spartan"/>
+                <a:sym typeface="League Spartan"/>
+              </a:rPr>
+              <a:t>N</a:t>
+            </a:r>
+            <a:r>
+              <a:rPr b="1" i="0" lang="en-US" sz="8545" u="none" cap="none" strike="noStrike">
+                <a:solidFill>
+                  <a:srgbClr val="F04E23"/>
+                </a:solidFill>
+                <a:latin typeface="League Spartan"/>
+                <a:ea typeface="League Spartan"/>
+                <a:cs typeface="League Spartan"/>
+                <a:sym typeface="League Spartan"/>
+              </a:rPr>
+              <a:t>eeds:</a:t>
             </a:r>
             <a:endParaRPr sz="600"/>
           </a:p>
@@ -24037,7 +24128,31 @@
                 <a:cs typeface="League Spartan"/>
                 <a:sym typeface="League Spartan"/>
               </a:rPr>
-              <a:t>Questions became needs:</a:t>
+              <a:t>Questions became </a:t>
+            </a:r>
+            <a:r>
+              <a:rPr b="1" lang="en-US" sz="8545">
+                <a:solidFill>
+                  <a:srgbClr val="F04E23"/>
+                </a:solidFill>
+                <a:latin typeface="League Spartan"/>
+                <a:ea typeface="League Spartan"/>
+                <a:cs typeface="League Spartan"/>
+                <a:sym typeface="League Spartan"/>
+              </a:rPr>
+              <a:t>N</a:t>
+            </a:r>
+            <a:r>
+              <a:rPr b="1" i="0" lang="en-US" sz="8545" u="none" cap="none" strike="noStrike">
+                <a:solidFill>
+                  <a:srgbClr val="F04E23"/>
+                </a:solidFill>
+                <a:latin typeface="League Spartan"/>
+                <a:ea typeface="League Spartan"/>
+                <a:cs typeface="League Spartan"/>
+                <a:sym typeface="League Spartan"/>
+              </a:rPr>
+              <a:t>eeds:</a:t>
             </a:r>
             <a:endParaRPr sz="600"/>
           </a:p>
@@ -24454,7 +24569,31 @@
                 <a:cs typeface="League Spartan"/>
                 <a:sym typeface="League Spartan"/>
               </a:rPr>
-              <a:t>Questions became needs:</a:t>
+              <a:t>Questions became </a:t>
+            </a:r>
+            <a:r>
+              <a:rPr b="1" lang="en-US" sz="8545">
+                <a:solidFill>
+                  <a:srgbClr val="F04E23"/>
+                </a:solidFill>
+                <a:latin typeface="League Spartan"/>
+                <a:ea typeface="League Spartan"/>
+                <a:cs typeface="League Spartan"/>
+                <a:sym typeface="League Spartan"/>
+              </a:rPr>
+              <a:t>N</a:t>
+            </a:r>
+            <a:r>
+              <a:rPr b="1" i="0" lang="en-US" sz="8545" u="none" cap="none" strike="noStrike">
+                <a:solidFill>
+                  <a:srgbClr val="F04E23"/>
+                </a:solidFill>
+                <a:latin typeface="League Spartan"/>
+                <a:ea typeface="League Spartan"/>
+                <a:cs typeface="League Spartan"/>
+                <a:sym typeface="League Spartan"/>
+              </a:rPr>
+              <a:t>eeds:</a:t>
             </a:r>
             <a:endParaRPr sz="600"/>
           </a:p>
@@ -29586,10 +29725,10 @@
                 <a:cs typeface="League Spartan"/>
                 <a:sym typeface="League Spartan"/>
               </a:rPr>
-              <a:t>IT’S AN </a:t>
-            </a:r>
-            <a:r>
-              <a:rPr b="1" lang="en-US" sz="6270" u="sng">
+              <a:t>YOUR </a:t>
+            </a:r>
+            <a:r>
+              <a:rPr b="1" i="1" lang="en-US" sz="6270">
                 <a:solidFill>
                   <a:srgbClr val="FFFFFF"/>
                 </a:solidFill>
@@ -33974,7 +34113,7 @@
               <a:t>It’s </a:t>
             </a:r>
             <a:r>
-              <a:rPr b="1" lang="en-US" sz="6270" u="sng">
+              <a:rPr b="1" i="1" lang="en-US" sz="6270">
                 <a:solidFill>
                   <a:srgbClr val="FFFFFF"/>
                 </a:solidFill>

</xml_diff>